<commit_message>
Disclaimer of AI use
</commit_message>
<xml_diff>
--- a/Paper-and-Pitch/Pitch.pptx
+++ b/Paper-and-Pitch/Pitch.pptx
@@ -5,6 +5,7 @@
     <p:sldMasterId xmlns:r="http://schemas.openxmlformats.org/officeDocument/2006/relationships" id="2147483648" r:id="Rb2b777ad7bb04d04"/>
   </p:sldMasterIdLst>
   <p:sldIdLst>
+    <p:sldId xmlns:ns0="http://schemas.openxmlformats.org/officeDocument/2006/relationships" id="267" ns0:id="rId16"/>
     <p:sldId xmlns:r="http://schemas.openxmlformats.org/officeDocument/2006/relationships" id="256" r:id="Red3ed0dd0cf04a76"/>
     <p:sldId xmlns:r="http://schemas.openxmlformats.org/officeDocument/2006/relationships" id="257" r:id="Reb73d3d5554e4a10"/>
     <p:sldId xmlns:r="http://schemas.openxmlformats.org/officeDocument/2006/relationships" id="258" r:id="R06cdf80096134266"/>
@@ -7290,6 +7291,78 @@
 </p:sld>
 </file>
 
+<file path=ppt/slides/slide12.xml><?xml version="1.0" encoding="utf-8"?>
+<p:sld xmlns:a="http://schemas.openxmlformats.org/drawingml/2006/main" xmlns:p="http://schemas.openxmlformats.org/presentationml/2006/main" xmlns:r="http://schemas.openxmlformats.org/officeDocument/2006/relationships">
+  <p:cSld>
+    <p:spTree>
+      <p:nvGrpSpPr>
+        <p:cNvPr id="1" name=""/>
+        <p:cNvGrpSpPr/>
+        <p:nvPr/>
+      </p:nvGrpSpPr>
+      <p:grpSpPr/>
+      <p:sp>
+        <p:nvSpPr>
+          <p:cNvPr id="2" name="TextBox 1"/>
+          <p:cNvSpPr txBox="1"/>
+          <p:nvPr/>
+        </p:nvSpPr>
+        <p:spPr>
+          <a:xfrm>
+            <a:off x="914400" y="914400"/>
+            <a:ext cx="7315200" cy="5029200"/>
+          </a:xfrm>
+          <a:prstGeom prst="rect">
+            <a:avLst/>
+          </a:prstGeom>
+          <a:noFill/>
+        </p:spPr>
+        <p:txBody>
+          <a:bodyPr wrap="square">
+            <a:spAutoFit/>
+          </a:bodyPr>
+          <a:lstStyle/>
+          <a:p/>
+          <a:p>
+            <a:pPr>
+              <a:defRPr b="1" sz="3200">
+                <a:solidFill>
+                  <a:srgbClr val="FF0000"/>
+                </a:solidFill>
+              </a:defRPr>
+            </a:pPr>
+            <a:r>
+              <a:t>DISCLAIMER: AI-ASSISTED LEARNING PROJECT</a:t>
+            </a:r>
+          </a:p>
+          <a:p>
+            <a:br/>
+            <a:pPr>
+              <a:defRPr sz="2400"/>
+            </a:pPr>
+            <a:r>
+              <a:t>This presentation and the accompanying repository are educational projects created for learning and experience.</a:t>
+            </a:r>
+          </a:p>
+          <a:p>
+            <a:br/>
+            <a:pPr>
+              <a:defRPr sz="2400"/>
+            </a:pPr>
+            <a:r>
+              <a:t>Large Language Models (AI) were used extensively to aid in completing, writing, and architecting this analysis pipeline and its documentation.</a:t>
+            </a:r>
+          </a:p>
+        </p:txBody>
+      </p:sp>
+    </p:spTree>
+  </p:cSld>
+  <p:clrMapOvr>
+    <a:masterClrMapping/>
+  </p:clrMapOvr>
+</p:sld>
+</file>
+
 <file path=ppt/slides/slide2.xml><?xml version="1.0" encoding="utf-8"?>
 <p:sld xmlns:p="http://schemas.openxmlformats.org/presentationml/2006/main">
   <p:cSld>

</xml_diff>

<commit_message>
Make mechanism-vs-mappability distinction prominent; add scope box
Adds a 'What this does and doesn't show' box high in the README and a matching
callout in the paper, drawing two lines the evidence supports and stopping short
of the overclaim it does not: (1) the temporal Nichols mechanism is untouched;
(2) present-day orbital surface TiO2 is not a usable global map-proxy in current
data -- but with ~40%% injection power and n_eff~1, that is failure-to-detect,
not proof of decoupling. Deck: closing slide now states 'a null here is
failure-to-detect, not disproof'; terrain slide drops the last 'suggestive'.
Guard test locks the distinction across README, paper, and deck.

Paper recompiled (6pp); deck PDF regenerated; both visually verified.
</commit_message>
<xml_diff>
--- a/Paper-and-Pitch/Pitch.pptx
+++ b/Paper-and-Pitch/Pitch.pptx
@@ -7002,7 +7002,7 @@
                 <a:ea typeface="Calibri"/>
                 <a:cs typeface="Calibri"/>
               </a:rPr>
-              <a:t>Treat this as a surface-proxy spatial study—not a temporal dynamo test.</a:t>
+              <a:t>A null here is failure-to-detect, not disproof: a surface-map co-location study, not a temporal dynamo test.</a:t>
             </a:r>
           </a:p>
         </p:txBody>
@@ -25732,7 +25732,7 @@
                 <a:ea typeface="Cambria"/>
                 <a:cs typeface="Cambria"/>
               </a:rPr>
-              <a:t>Mapped mare-proxy TiO₂ is suggestive but unstable</a:t>
+              <a:t>Mapped mare-proxy TiO₂ is positive but not significant</a:t>
             </a:r>
           </a:p>
         </p:txBody>

</xml_diff>